<commit_message>
Preserve reconstruction intent and verify actual rendered content
</commit_message>
<xml_diff>
--- a/examples/consulting-ai-transformation/run/slides/s01-recommendation/deliverables/slide.pptx
+++ b/examples/consulting-ai-transformation/run/slides/s01-recommendation/deliverables/slide.pptx
@@ -506,7 +506,7 @@
 The 95% gate applies to a sampled test set. Each client release separately requires expert verification and engagement-lead approval.
 At least 11 of 15 pilot users must be weekly active. One comparable research task is measured per pilot engagement.
 [SlidePoise sources]
-Generated target visual: /private/tmp/.slidepoise-rebuild-h51errnw/slides/s01-recommendation/work/accepted-slide.png
+Generated target visual: /Users/henry/Codes/AI_slide_drafting/examples/consulting-ai-transformation/run/slides/s01-recommendation/work/accepted-slide.png
 Canonical asset remix-focus-2-line: /Users/henry/Codes/AI_slide_drafting/examples/consulting-ai-transformation/run/work/icon-cache/focus-2/remix-focus-2-line.svg
 Canonical asset remix-team-line: /Users/henry/Codes/AI_slide_drafting/examples/consulting-ai-transformation/run/work/icon-cache/team/remix-team-line.svg
 Canonical asset remix-shield-check-line: /Users/henry/Codes/AI_slide_drafting/examples/consulting-ai-transformation/run/work/icon-cache/shield-check/remix-shield-check-line.svg</a:t>
@@ -1229,8 +1229,8 @@
         </p:nvSpPr>
         <p:spPr>
           <a:xfrm>
-            <a:off x="4108450" y="1524000"/>
-            <a:ext cx="6350" cy="876300"/>
+            <a:off x="4076700" y="1739900"/>
+            <a:ext cx="6350" cy="889000"/>
           </a:xfrm>
           <a:prstGeom prst="rect">
             <a:avLst/>
@@ -1256,8 +1256,8 @@
         </p:nvSpPr>
         <p:spPr>
           <a:xfrm>
-            <a:off x="8210550" y="1524000"/>
-            <a:ext cx="6350" cy="876300"/>
+            <a:off x="8337550" y="1739900"/>
+            <a:ext cx="6350" cy="889000"/>
           </a:xfrm>
           <a:prstGeom prst="rect">
             <a:avLst/>
@@ -1344,18 +1344,18 @@
           </p:nvPr>
         </p:nvGraphicFramePr>
         <p:xfrm>
-          <a:off x="6781800" y="2959100"/>
-          <a:ext cx="5080000" cy="2108200"/>
+          <a:off x="6731000" y="3251200"/>
+          <a:ext cx="5207000" cy="2120900"/>
         </p:xfrm>
         <a:graphic>
           <a:graphicData uri="http://schemas.openxmlformats.org/drawingml/2006/table">
             <a:tbl>
               <a:tblPr/>
               <a:tblGrid>
-                <a:gridCol w="2794000"/>
-                <a:gridCol w="2286000"/>
+                <a:gridCol w="2857500"/>
+                <a:gridCol w="2349500"/>
               </a:tblGrid>
-              <a:tr h="342900">
+              <a:tr h="381000">
                 <a:tc>
                   <a:txBody>
                     <a:bodyPr>
@@ -1367,7 +1367,7 @@
                         <a:buNone/>
                       </a:pPr>
                       <a:r>
-                        <a:rPr lang="en-US" sz="1100" b="1" dirty="0">
+                        <a:rPr lang="en-US" sz="1200" b="1" dirty="0">
                           <a:solidFill>
                             <a:srgbClr val="FFFFFF"/>
                           </a:solidFill>
@@ -1377,14 +1377,14 @@
                         </a:rPr>
                         <a:t>Measure</a:t>
                       </a:r>
-                      <a:endParaRPr lang="en-US" sz="1100" dirty="0">
+                      <a:endParaRPr lang="en-US" sz="1200" dirty="0">
                         <a:latin typeface="Arial" charset="0"/>
                         <a:ea typeface="Arial" charset="0"/>
                         <a:cs typeface="Arial" charset="0"/>
                       </a:endParaRPr>
                     </a:p>
                   </a:txBody>
-                  <a:tcPr marL="101600" marR="101600" marT="38100" marB="38100" anchor="ctr">
+                  <a:tcPr marL="76200" marR="76200" marT="31750" marB="31750" anchor="ctr">
                     <a:lnL w="6350" cap="flat" cmpd="sng" algn="ctr">
                       <a:solidFill>
                         <a:srgbClr val="C6C9CD"/>
@@ -1433,11 +1433,11 @@
                     </a:bodyPr>
                     <a:lstStyle/>
                     <a:p>
-                      <a:pPr algn="ctr" indent="0" marL="0">
+                      <a:pPr algn="l" indent="0" marL="0">
                         <a:buNone/>
                       </a:pPr>
                       <a:r>
-                        <a:rPr lang="en-US" sz="1100" b="1" dirty="0">
+                        <a:rPr lang="en-US" sz="1200" b="1" dirty="0">
                           <a:solidFill>
                             <a:srgbClr val="FFFFFF"/>
                           </a:solidFill>
@@ -1447,14 +1447,14 @@
                         </a:rPr>
                         <a:t>Minimum to scale</a:t>
                       </a:r>
-                      <a:endParaRPr lang="en-US" sz="1100" dirty="0">
+                      <a:endParaRPr lang="en-US" sz="1200" dirty="0">
                         <a:latin typeface="Arial" charset="0"/>
                         <a:ea typeface="Arial" charset="0"/>
                         <a:cs typeface="Arial" charset="0"/>
                       </a:endParaRPr>
                     </a:p>
                   </a:txBody>
-                  <a:tcPr marL="101600" marR="101600" marT="38100" marB="38100" anchor="ctr">
+                  <a:tcPr marL="76200" marR="76200" marT="31750" marB="31750" anchor="ctr">
                     <a:lnL w="6350" cap="flat" cmpd="sng" algn="ctr">
                       <a:solidFill>
                         <a:srgbClr val="C6C9CD"/>
@@ -1497,7 +1497,7 @@
                   </a:tcPr>
                 </a:tc>
               </a:tr>
-              <a:tr h="438150">
+              <a:tr h="431800">
                 <a:tc>
                   <a:txBody>
                     <a:bodyPr>
@@ -1509,7 +1509,7 @@
                         <a:buNone/>
                       </a:pPr>
                       <a:r>
-                        <a:rPr lang="en-US" sz="1100" b="1" dirty="0">
+                        <a:rPr lang="en-US" sz="1200" b="1" dirty="0">
                           <a:solidFill>
                             <a:srgbClr val="000000"/>
                           </a:solidFill>
@@ -1519,14 +1519,14 @@
                         </a:rPr>
                         <a:t>Cycle-time reduction</a:t>
                       </a:r>
-                      <a:endParaRPr lang="en-US" sz="1100" dirty="0">
+                      <a:endParaRPr lang="en-US" sz="1200" dirty="0">
                         <a:latin typeface="Arial" charset="0"/>
                         <a:ea typeface="Arial" charset="0"/>
                         <a:cs typeface="Arial" charset="0"/>
                       </a:endParaRPr>
                     </a:p>
                   </a:txBody>
-                  <a:tcPr marL="101600" marR="101600" marT="38100" marB="38100" anchor="ctr">
+                  <a:tcPr marL="76200" marR="76200" marT="31750" marB="31750" anchor="ctr">
                     <a:lnL w="6350" cap="flat" cmpd="sng" algn="ctr">
                       <a:solidFill>
                         <a:srgbClr val="C6C9CD"/>
@@ -1575,11 +1575,11 @@
                     </a:bodyPr>
                     <a:lstStyle/>
                     <a:p>
-                      <a:pPr algn="ctr" indent="0" marL="0">
+                      <a:pPr algn="l" indent="0" marL="0">
                         <a:buNone/>
                       </a:pPr>
                       <a:r>
-                        <a:rPr lang="en-US" sz="1100" dirty="0">
+                        <a:rPr lang="en-US" sz="1200" dirty="0">
                           <a:solidFill>
                             <a:srgbClr val="000000"/>
                           </a:solidFill>
@@ -1589,14 +1589,14 @@
                         </a:rPr>
                         <a:t>25%</a:t>
                       </a:r>
-                      <a:endParaRPr lang="en-US" sz="1100" dirty="0">
+                      <a:endParaRPr lang="en-US" sz="1200" dirty="0">
                         <a:latin typeface="Arial" charset="0"/>
                         <a:ea typeface="Arial" charset="0"/>
                         <a:cs typeface="Arial" charset="0"/>
                       </a:endParaRPr>
                     </a:p>
                   </a:txBody>
-                  <a:tcPr marL="101600" marR="101600" marT="38100" marB="38100" anchor="ctr">
+                  <a:tcPr marL="76200" marR="76200" marT="31750" marB="31750" anchor="ctr">
                     <a:lnL w="6350" cap="flat" cmpd="sng" algn="ctr">
                       <a:solidFill>
                         <a:srgbClr val="C6C9CD"/>
@@ -1639,7 +1639,7 @@
                   </a:tcPr>
                 </a:tc>
               </a:tr>
-              <a:tr h="438150">
+              <a:tr h="431800">
                 <a:tc>
                   <a:txBody>
                     <a:bodyPr>
@@ -1651,7 +1651,7 @@
                         <a:buNone/>
                       </a:pPr>
                       <a:r>
-                        <a:rPr lang="en-US" sz="1100" b="1" dirty="0">
+                        <a:rPr lang="en-US" sz="1200" b="1" dirty="0">
                           <a:solidFill>
                             <a:srgbClr val="000000"/>
                           </a:solidFill>
@@ -1661,14 +1661,14 @@
                         </a:rPr>
                         <a:t>Sampled cited claims verified</a:t>
                       </a:r>
-                      <a:endParaRPr lang="en-US" sz="1100" dirty="0">
+                      <a:endParaRPr lang="en-US" sz="1200" dirty="0">
                         <a:latin typeface="Arial" charset="0"/>
                         <a:ea typeface="Arial" charset="0"/>
                         <a:cs typeface="Arial" charset="0"/>
                       </a:endParaRPr>
                     </a:p>
                   </a:txBody>
-                  <a:tcPr marL="101600" marR="101600" marT="38100" marB="38100" anchor="ctr">
+                  <a:tcPr marL="76200" marR="76200" marT="31750" marB="31750" anchor="ctr">
                     <a:lnL w="6350" cap="flat" cmpd="sng" algn="ctr">
                       <a:solidFill>
                         <a:srgbClr val="C6C9CD"/>
@@ -1717,11 +1717,11 @@
                     </a:bodyPr>
                     <a:lstStyle/>
                     <a:p>
-                      <a:pPr algn="ctr" indent="0" marL="0">
+                      <a:pPr algn="l" indent="0" marL="0">
                         <a:buNone/>
                       </a:pPr>
                       <a:r>
-                        <a:rPr lang="en-US" sz="1100" dirty="0">
+                        <a:rPr lang="en-US" sz="1200" dirty="0">
                           <a:solidFill>
                             <a:srgbClr val="000000"/>
                           </a:solidFill>
@@ -1731,14 +1731,14 @@
                         </a:rPr>
                         <a:t>95%</a:t>
                       </a:r>
-                      <a:endParaRPr lang="en-US" sz="1100" dirty="0">
+                      <a:endParaRPr lang="en-US" sz="1200" dirty="0">
                         <a:latin typeface="Arial" charset="0"/>
                         <a:ea typeface="Arial" charset="0"/>
                         <a:cs typeface="Arial" charset="0"/>
                       </a:endParaRPr>
                     </a:p>
                   </a:txBody>
-                  <a:tcPr marL="101600" marR="101600" marT="38100" marB="38100" anchor="ctr">
+                  <a:tcPr marL="76200" marR="76200" marT="31750" marB="31750" anchor="ctr">
                     <a:lnL w="6350" cap="flat" cmpd="sng" algn="ctr">
                       <a:solidFill>
                         <a:srgbClr val="C6C9CD"/>
@@ -1781,7 +1781,7 @@
                   </a:tcPr>
                 </a:tc>
               </a:tr>
-              <a:tr h="438150">
+              <a:tr h="431800">
                 <a:tc>
                   <a:txBody>
                     <a:bodyPr>
@@ -1793,7 +1793,7 @@
                         <a:buNone/>
                       </a:pPr>
                       <a:r>
-                        <a:rPr lang="en-US" sz="1100" b="1" dirty="0">
+                        <a:rPr lang="en-US" sz="1200" b="1" dirty="0">
                           <a:solidFill>
                             <a:srgbClr val="000000"/>
                           </a:solidFill>
@@ -1803,14 +1803,14 @@
                         </a:rPr>
                         <a:t>Critical data exceptions</a:t>
                       </a:r>
-                      <a:endParaRPr lang="en-US" sz="1100" dirty="0">
+                      <a:endParaRPr lang="en-US" sz="1200" dirty="0">
                         <a:latin typeface="Arial" charset="0"/>
                         <a:ea typeface="Arial" charset="0"/>
                         <a:cs typeface="Arial" charset="0"/>
                       </a:endParaRPr>
                     </a:p>
                   </a:txBody>
-                  <a:tcPr marL="101600" marR="101600" marT="38100" marB="38100" anchor="ctr">
+                  <a:tcPr marL="76200" marR="76200" marT="31750" marB="31750" anchor="ctr">
                     <a:lnL w="6350" cap="flat" cmpd="sng" algn="ctr">
                       <a:solidFill>
                         <a:srgbClr val="C6C9CD"/>
@@ -1859,11 +1859,11 @@
                     </a:bodyPr>
                     <a:lstStyle/>
                     <a:p>
-                      <a:pPr algn="ctr" indent="0" marL="0">
+                      <a:pPr algn="l" indent="0" marL="0">
                         <a:buNone/>
                       </a:pPr>
                       <a:r>
-                        <a:rPr lang="en-US" sz="1100" dirty="0">
+                        <a:rPr lang="en-US" sz="1200" dirty="0">
                           <a:solidFill>
                             <a:srgbClr val="000000"/>
                           </a:solidFill>
@@ -1873,14 +1873,14 @@
                         </a:rPr>
                         <a:t>0</a:t>
                       </a:r>
-                      <a:endParaRPr lang="en-US" sz="1100" dirty="0">
+                      <a:endParaRPr lang="en-US" sz="1200" dirty="0">
                         <a:latin typeface="Arial" charset="0"/>
                         <a:ea typeface="Arial" charset="0"/>
                         <a:cs typeface="Arial" charset="0"/>
                       </a:endParaRPr>
                     </a:p>
                   </a:txBody>
-                  <a:tcPr marL="101600" marR="101600" marT="38100" marB="38100" anchor="ctr">
+                  <a:tcPr marL="76200" marR="76200" marT="31750" marB="31750" anchor="ctr">
                     <a:lnL w="6350" cap="flat" cmpd="sng" algn="ctr">
                       <a:solidFill>
                         <a:srgbClr val="C6C9CD"/>
@@ -1923,7 +1923,7 @@
                   </a:tcPr>
                 </a:tc>
               </a:tr>
-              <a:tr h="450850">
+              <a:tr h="444500">
                 <a:tc>
                   <a:txBody>
                     <a:bodyPr>
@@ -1935,7 +1935,7 @@
                         <a:buNone/>
                       </a:pPr>
                       <a:r>
-                        <a:rPr lang="en-US" sz="1100" b="1" dirty="0">
+                        <a:rPr lang="en-US" sz="1200" b="1" dirty="0">
                           <a:solidFill>
                             <a:srgbClr val="000000"/>
                           </a:solidFill>
@@ -1945,14 +1945,14 @@
                         </a:rPr>
                         <a:t>Weekly-active pilot users</a:t>
                       </a:r>
-                      <a:endParaRPr lang="en-US" sz="1100" dirty="0">
+                      <a:endParaRPr lang="en-US" sz="1200" dirty="0">
                         <a:latin typeface="Arial" charset="0"/>
                         <a:ea typeface="Arial" charset="0"/>
                         <a:cs typeface="Arial" charset="0"/>
                       </a:endParaRPr>
                     </a:p>
                   </a:txBody>
-                  <a:tcPr marL="101600" marR="101600" marT="38100" marB="38100" anchor="ctr">
+                  <a:tcPr marL="76200" marR="76200" marT="31750" marB="31750" anchor="ctr">
                     <a:lnL w="6350" cap="flat" cmpd="sng" algn="ctr">
                       <a:solidFill>
                         <a:srgbClr val="C6C9CD"/>
@@ -2001,11 +2001,11 @@
                     </a:bodyPr>
                     <a:lstStyle/>
                     <a:p>
-                      <a:pPr algn="ctr" indent="0" marL="0">
+                      <a:pPr algn="l" indent="0" marL="0">
                         <a:buNone/>
                       </a:pPr>
                       <a:r>
-                        <a:rPr lang="en-US" sz="1100" dirty="0">
+                        <a:rPr lang="en-US" sz="1200" dirty="0">
                           <a:solidFill>
                             <a:srgbClr val="000000"/>
                           </a:solidFill>
@@ -2015,14 +2015,14 @@
                         </a:rPr>
                         <a:t>70% · at least 11 of 15</a:t>
                       </a:r>
-                      <a:endParaRPr lang="en-US" sz="1100" dirty="0">
+                      <a:endParaRPr lang="en-US" sz="1200" dirty="0">
                         <a:latin typeface="Arial" charset="0"/>
                         <a:ea typeface="Arial" charset="0"/>
                         <a:cs typeface="Arial" charset="0"/>
                       </a:endParaRPr>
                     </a:p>
                   </a:txBody>
-                  <a:tcPr marL="101600" marR="101600" marT="38100" marB="38100" anchor="ctr">
+                  <a:tcPr marL="76200" marR="76200" marT="31750" marB="31750" anchor="ctr">
                     <a:lnL w="6350" cap="flat" cmpd="sng" algn="ctr">
                       <a:solidFill>
                         <a:srgbClr val="C6C9CD"/>
@@ -2167,8 +2167,8 @@
         </p:nvSpPr>
         <p:spPr>
           <a:xfrm>
-            <a:off x="298450" y="1524000"/>
-            <a:ext cx="3175000" cy="444500"/>
+            <a:off x="298450" y="1619250"/>
+            <a:ext cx="3175000" cy="596900"/>
           </a:xfrm>
           <a:prstGeom prst="rect">
             <a:avLst/>
@@ -2190,7 +2190,7 @@
               <a:defRPr spc="0"/>
             </a:pPr>
             <a:r>
-              <a:rPr lang="en-US" sz="2900" b="1" dirty="0" spc="0">
+              <a:rPr lang="en-US" sz="4000" b="1" dirty="0" spc="0">
                 <a:solidFill>
                   <a:srgbClr val="FD5108"/>
                 </a:solidFill>
@@ -2200,7 +2200,7 @@
               </a:rPr>
               <a:t>10,800 h</a:t>
             </a:r>
-            <a:endParaRPr lang="en-US" sz="2900" dirty="0" spc="0"/>
+            <a:endParaRPr lang="en-US" sz="4000" dirty="0" spc="0"/>
           </a:p>
         </p:txBody>
       </p:sp>
@@ -2212,8 +2212,8 @@
         </p:nvSpPr>
         <p:spPr>
           <a:xfrm>
-            <a:off x="298450" y="1981200"/>
-            <a:ext cx="3302000" cy="203200"/>
+            <a:off x="298450" y="2197100"/>
+            <a:ext cx="3175000" cy="241300"/>
           </a:xfrm>
           <a:prstGeom prst="rect">
             <a:avLst/>
@@ -2235,7 +2235,7 @@
               <a:defRPr spc="0"/>
             </a:pPr>
             <a:r>
-              <a:rPr lang="en-US" sz="1250" b="1" dirty="0" spc="0">
+              <a:rPr lang="en-US" sz="1400" b="1" dirty="0" spc="0">
                 <a:solidFill>
                   <a:srgbClr val="000000"/>
                 </a:solidFill>
@@ -2245,7 +2245,7 @@
               </a:rPr>
               <a:t>Annual research baseline</a:t>
             </a:r>
-            <a:endParaRPr lang="en-US" sz="1250" dirty="0" spc="0"/>
+            <a:endParaRPr lang="en-US" sz="1400" dirty="0" spc="0"/>
           </a:p>
         </p:txBody>
       </p:sp>
@@ -2257,8 +2257,8 @@
         </p:nvSpPr>
         <p:spPr>
           <a:xfrm>
-            <a:off x="298450" y="2197100"/>
-            <a:ext cx="3302000" cy="203200"/>
+            <a:off x="298450" y="2476500"/>
+            <a:ext cx="3175000" cy="266700"/>
           </a:xfrm>
           <a:prstGeom prst="rect">
             <a:avLst/>
@@ -2280,7 +2280,7 @@
               <a:defRPr spc="0"/>
             </a:pPr>
             <a:r>
-              <a:rPr lang="en-US" sz="1150" dirty="0" spc="0">
+              <a:rPr lang="en-US" sz="1300" dirty="0" spc="0">
                 <a:solidFill>
                   <a:srgbClr val="000000"/>
                 </a:solidFill>
@@ -2290,7 +2290,7 @@
               </a:rPr>
               <a:t>900 engagements × 12 h</a:t>
             </a:r>
-            <a:endParaRPr lang="en-US" sz="1150" dirty="0" spc="0"/>
+            <a:endParaRPr lang="en-US" sz="1300" dirty="0" spc="0"/>
           </a:p>
         </p:txBody>
       </p:sp>
@@ -2302,8 +2302,8 @@
         </p:nvSpPr>
         <p:spPr>
           <a:xfrm>
-            <a:off x="4406900" y="1524000"/>
-            <a:ext cx="3175000" cy="444500"/>
+            <a:off x="4584700" y="1619250"/>
+            <a:ext cx="3175000" cy="596900"/>
           </a:xfrm>
           <a:prstGeom prst="rect">
             <a:avLst/>
@@ -2325,7 +2325,7 @@
               <a:defRPr spc="0"/>
             </a:pPr>
             <a:r>
-              <a:rPr lang="en-US" sz="2900" b="1" dirty="0" spc="0">
+              <a:rPr lang="en-US" sz="4000" b="1" dirty="0" spc="0">
                 <a:solidFill>
                   <a:srgbClr val="FD5108"/>
                 </a:solidFill>
@@ -2335,7 +2335,7 @@
               </a:rPr>
               <a:t>1,944 h</a:t>
             </a:r>
-            <a:endParaRPr lang="en-US" sz="2900" dirty="0" spc="0"/>
+            <a:endParaRPr lang="en-US" sz="4000" dirty="0" spc="0"/>
           </a:p>
         </p:txBody>
       </p:sp>
@@ -2347,8 +2347,8 @@
         </p:nvSpPr>
         <p:spPr>
           <a:xfrm>
-            <a:off x="4406900" y="1981200"/>
-            <a:ext cx="3302000" cy="203200"/>
+            <a:off x="4584700" y="2197100"/>
+            <a:ext cx="3175000" cy="241300"/>
           </a:xfrm>
           <a:prstGeom prst="rect">
             <a:avLst/>
@@ -2370,7 +2370,7 @@
               <a:defRPr spc="0"/>
             </a:pPr>
             <a:r>
-              <a:rPr lang="en-US" sz="1250" b="1" dirty="0" spc="0">
+              <a:rPr lang="en-US" sz="1400" b="1" dirty="0" spc="0">
                 <a:solidFill>
                   <a:srgbClr val="000000"/>
                 </a:solidFill>
@@ -2380,7 +2380,7 @@
               </a:rPr>
               <a:t>Potential annual capacity</a:t>
             </a:r>
-            <a:endParaRPr lang="en-US" sz="1250" dirty="0" spc="0"/>
+            <a:endParaRPr lang="en-US" sz="1400" dirty="0" spc="0"/>
           </a:p>
         </p:txBody>
       </p:sp>
@@ -2392,8 +2392,8 @@
         </p:nvSpPr>
         <p:spPr>
           <a:xfrm>
-            <a:off x="4406900" y="2197100"/>
-            <a:ext cx="3302000" cy="203200"/>
+            <a:off x="4584700" y="2476500"/>
+            <a:ext cx="3175000" cy="266700"/>
           </a:xfrm>
           <a:prstGeom prst="rect">
             <a:avLst/>
@@ -2415,7 +2415,7 @@
               <a:defRPr spc="0"/>
             </a:pPr>
             <a:r>
-              <a:rPr lang="en-US" sz="1150" dirty="0" spc="0">
+              <a:rPr lang="en-US" sz="1300" dirty="0" spc="0">
                 <a:solidFill>
                   <a:srgbClr val="000000"/>
                 </a:solidFill>
@@ -2425,7 +2425,7 @@
               </a:rPr>
               <a:t>60% adoption × 30% time reduction</a:t>
             </a:r>
-            <a:endParaRPr lang="en-US" sz="1150" dirty="0" spc="0"/>
+            <a:endParaRPr lang="en-US" sz="1300" dirty="0" spc="0"/>
           </a:p>
         </p:txBody>
       </p:sp>
@@ -2437,8 +2437,8 @@
         </p:nvSpPr>
         <p:spPr>
           <a:xfrm>
-            <a:off x="8509000" y="1524000"/>
-            <a:ext cx="3175000" cy="444500"/>
+            <a:off x="8940800" y="1619250"/>
+            <a:ext cx="3175000" cy="596900"/>
           </a:xfrm>
           <a:prstGeom prst="rect">
             <a:avLst/>
@@ -2460,7 +2460,7 @@
               <a:defRPr spc="0"/>
             </a:pPr>
             <a:r>
-              <a:rPr lang="en-US" sz="2900" b="1" dirty="0" spc="0">
+              <a:rPr lang="en-US" sz="4000" b="1" dirty="0" spc="0">
                 <a:solidFill>
                   <a:srgbClr val="FD5108"/>
                 </a:solidFill>
@@ -2470,7 +2470,7 @@
               </a:rPr>
               <a:t>$243k</a:t>
             </a:r>
-            <a:endParaRPr lang="en-US" sz="2900" dirty="0" spc="0"/>
+            <a:endParaRPr lang="en-US" sz="4000" dirty="0" spc="0"/>
           </a:p>
         </p:txBody>
       </p:sp>
@@ -2482,8 +2482,8 @@
         </p:nvSpPr>
         <p:spPr>
           <a:xfrm>
-            <a:off x="8509000" y="1981200"/>
-            <a:ext cx="3302000" cy="203200"/>
+            <a:off x="8940800" y="2197100"/>
+            <a:ext cx="3175000" cy="241300"/>
           </a:xfrm>
           <a:prstGeom prst="rect">
             <a:avLst/>
@@ -2505,7 +2505,7 @@
               <a:defRPr spc="0"/>
             </a:pPr>
             <a:r>
-              <a:rPr lang="en-US" sz="1250" b="1" dirty="0" spc="0">
+              <a:rPr lang="en-US" sz="1400" b="1" dirty="0" spc="0">
                 <a:solidFill>
                   <a:srgbClr val="000000"/>
                 </a:solidFill>
@@ -2515,7 +2515,7 @@
               </a:rPr>
               <a:t>Annual capacity equivalent</a:t>
             </a:r>
-            <a:endParaRPr lang="en-US" sz="1250" dirty="0" spc="0"/>
+            <a:endParaRPr lang="en-US" sz="1400" dirty="0" spc="0"/>
           </a:p>
         </p:txBody>
       </p:sp>
@@ -2527,8 +2527,8 @@
         </p:nvSpPr>
         <p:spPr>
           <a:xfrm>
-            <a:off x="8509000" y="2197100"/>
-            <a:ext cx="3302000" cy="203200"/>
+            <a:off x="8940800" y="2476500"/>
+            <a:ext cx="3175000" cy="266700"/>
           </a:xfrm>
           <a:prstGeom prst="rect">
             <a:avLst/>
@@ -2550,7 +2550,7 @@
               <a:defRPr spc="0"/>
             </a:pPr>
             <a:r>
-              <a:rPr lang="en-US" sz="1150" dirty="0" spc="0">
+              <a:rPr lang="en-US" sz="1300" dirty="0" spc="0">
                 <a:solidFill>
                   <a:srgbClr val="000000"/>
                 </a:solidFill>
@@ -2560,7 +2560,7 @@
               </a:rPr>
               <a:t>1,944 h × $125 per hour</a:t>
             </a:r>
-            <a:endParaRPr lang="en-US" sz="1150" dirty="0" spc="0"/>
+            <a:endParaRPr lang="en-US" sz="1300" dirty="0" spc="0"/>
           </a:p>
         </p:txBody>
       </p:sp>
@@ -2572,8 +2572,8 @@
         </p:nvSpPr>
         <p:spPr>
           <a:xfrm>
-            <a:off x="298450" y="2667000"/>
-            <a:ext cx="5397500" cy="266700"/>
+            <a:off x="298450" y="2927350"/>
+            <a:ext cx="5778500" cy="266700"/>
           </a:xfrm>
           <a:prstGeom prst="rect">
             <a:avLst/>
@@ -2595,7 +2595,7 @@
               <a:defRPr spc="0"/>
             </a:pPr>
             <a:r>
-              <a:rPr lang="en-US" sz="1350" b="1" dirty="0" spc="0">
+              <a:rPr lang="en-US" sz="1400" b="1" dirty="0" spc="0">
                 <a:solidFill>
                   <a:srgbClr val="000000"/>
                 </a:solidFill>
@@ -2605,7 +2605,7 @@
               </a:rPr>
               <a:t>WHY THIS PILOT FIRST</a:t>
             </a:r>
-            <a:endParaRPr lang="en-US" sz="1350" dirty="0" spc="0"/>
+            <a:endParaRPr lang="en-US" sz="1400" dirty="0" spc="0"/>
           </a:p>
         </p:txBody>
       </p:sp>
@@ -2617,8 +2617,8 @@
         </p:nvSpPr>
         <p:spPr>
           <a:xfrm>
-            <a:off x="1047750" y="3092450"/>
-            <a:ext cx="393700" cy="279400"/>
+            <a:off x="1358900" y="3302000"/>
+            <a:ext cx="412750" cy="254000"/>
           </a:xfrm>
           <a:prstGeom prst="rect">
             <a:avLst/>
@@ -2640,7 +2640,7 @@
               <a:defRPr spc="0"/>
             </a:pPr>
             <a:r>
-              <a:rPr lang="en-US" sz="1250" b="1" dirty="0" spc="0">
+              <a:rPr lang="en-US" sz="1500" b="1" dirty="0" spc="0">
                 <a:solidFill>
                   <a:srgbClr val="000000"/>
                 </a:solidFill>
@@ -2650,7 +2650,7 @@
               </a:rPr>
               <a:t>01</a:t>
             </a:r>
-            <a:endParaRPr lang="en-US" sz="1250" dirty="0" spc="0"/>
+            <a:endParaRPr lang="en-US" sz="1500" dirty="0" spc="0"/>
           </a:p>
         </p:txBody>
       </p:sp>
@@ -2662,8 +2662,8 @@
         </p:nvSpPr>
         <p:spPr>
           <a:xfrm>
-            <a:off x="1619250" y="3073400"/>
-            <a:ext cx="3429000" cy="222250"/>
+            <a:off x="1936750" y="3314700"/>
+            <a:ext cx="4445000" cy="241300"/>
           </a:xfrm>
           <a:prstGeom prst="rect">
             <a:avLst/>
@@ -2685,7 +2685,7 @@
               <a:defRPr spc="0"/>
             </a:pPr>
             <a:r>
-              <a:rPr lang="en-US" sz="1250" b="1" dirty="0" spc="0">
+              <a:rPr lang="en-US" sz="1400" b="1" dirty="0" spc="0">
                 <a:solidFill>
                   <a:srgbClr val="000000"/>
                 </a:solidFill>
@@ -2695,7 +2695,7 @@
               </a:rPr>
               <a:t>Focus a repeatable task</a:t>
             </a:r>
-            <a:endParaRPr lang="en-US" sz="1250" dirty="0" spc="0"/>
+            <a:endParaRPr lang="en-US" sz="1400" dirty="0" spc="0"/>
           </a:p>
         </p:txBody>
       </p:sp>
@@ -2707,8 +2707,8 @@
         </p:nvSpPr>
         <p:spPr>
           <a:xfrm>
-            <a:off x="1619250" y="3314700"/>
-            <a:ext cx="4445000" cy="254000"/>
+            <a:off x="1936750" y="3581400"/>
+            <a:ext cx="4635500" cy="412750"/>
           </a:xfrm>
           <a:prstGeom prst="rect">
             <a:avLst/>
@@ -2730,7 +2730,7 @@
               <a:defRPr spc="0"/>
             </a:pPr>
             <a:r>
-              <a:rPr lang="en-US" sz="1050" dirty="0" spc="0">
+              <a:rPr lang="en-US" sz="1300" dirty="0" spc="0">
                 <a:solidFill>
                   <a:srgbClr val="000000"/>
                 </a:solidFill>
@@ -2740,7 +2740,7 @@
               </a:rPr>
               <a:t>Approved sources, frequent use and comparable inputs.</a:t>
             </a:r>
-            <a:endParaRPr lang="en-US" sz="1050" dirty="0" spc="0"/>
+            <a:endParaRPr lang="en-US" sz="1300" dirty="0" spc="0"/>
           </a:p>
         </p:txBody>
       </p:sp>
@@ -2752,8 +2752,8 @@
         </p:nvSpPr>
         <p:spPr>
           <a:xfrm>
-            <a:off x="1047750" y="3771900"/>
-            <a:ext cx="393700" cy="279400"/>
+            <a:off x="1358900" y="4089400"/>
+            <a:ext cx="412750" cy="254000"/>
           </a:xfrm>
           <a:prstGeom prst="rect">
             <a:avLst/>
@@ -2775,7 +2775,7 @@
               <a:defRPr spc="0"/>
             </a:pPr>
             <a:r>
-              <a:rPr lang="en-US" sz="1250" b="1" dirty="0" spc="0">
+              <a:rPr lang="en-US" sz="1500" b="1" dirty="0" spc="0">
                 <a:solidFill>
                   <a:srgbClr val="000000"/>
                 </a:solidFill>
@@ -2785,7 +2785,7 @@
               </a:rPr>
               <a:t>02</a:t>
             </a:r>
-            <a:endParaRPr lang="en-US" sz="1250" dirty="0" spc="0"/>
+            <a:endParaRPr lang="en-US" sz="1500" dirty="0" spc="0"/>
           </a:p>
         </p:txBody>
       </p:sp>
@@ -2797,8 +2797,8 @@
         </p:nvSpPr>
         <p:spPr>
           <a:xfrm>
-            <a:off x="1619250" y="3752850"/>
-            <a:ext cx="3429000" cy="222250"/>
+            <a:off x="1936750" y="4102100"/>
+            <a:ext cx="4445000" cy="241300"/>
           </a:xfrm>
           <a:prstGeom prst="rect">
             <a:avLst/>
@@ -2820,7 +2820,7 @@
               <a:defRPr spc="0"/>
             </a:pPr>
             <a:r>
-              <a:rPr lang="en-US" sz="1250" b="1" dirty="0" spc="0">
+              <a:rPr lang="en-US" sz="1400" b="1" dirty="0" spc="0">
                 <a:solidFill>
                   <a:srgbClr val="000000"/>
                 </a:solidFill>
@@ -2830,7 +2830,7 @@
               </a:rPr>
               <a:t>Preserve expert review</a:t>
             </a:r>
-            <a:endParaRPr lang="en-US" sz="1250" dirty="0" spc="0"/>
+            <a:endParaRPr lang="en-US" sz="1400" dirty="0" spc="0"/>
           </a:p>
         </p:txBody>
       </p:sp>
@@ -2842,8 +2842,8 @@
         </p:nvSpPr>
         <p:spPr>
           <a:xfrm>
-            <a:off x="1619250" y="3994150"/>
-            <a:ext cx="4445000" cy="254000"/>
+            <a:off x="1936750" y="4368800"/>
+            <a:ext cx="4635500" cy="412750"/>
           </a:xfrm>
           <a:prstGeom prst="rect">
             <a:avLst/>
@@ -2865,7 +2865,7 @@
               <a:defRPr spc="0"/>
             </a:pPr>
             <a:r>
-              <a:rPr lang="en-US" sz="1050" dirty="0" spc="0">
+              <a:rPr lang="en-US" sz="1300" dirty="0" spc="0">
                 <a:solidFill>
                   <a:srgbClr val="000000"/>
                 </a:solidFill>
@@ -2875,7 +2875,7 @@
               </a:rPr>
               <a:t>Verify every client claim before release.</a:t>
             </a:r>
-            <a:endParaRPr lang="en-US" sz="1050" dirty="0" spc="0"/>
+            <a:endParaRPr lang="en-US" sz="1300" dirty="0" spc="0"/>
           </a:p>
         </p:txBody>
       </p:sp>
@@ -2887,8 +2887,8 @@
         </p:nvSpPr>
         <p:spPr>
           <a:xfrm>
-            <a:off x="1047750" y="4451350"/>
-            <a:ext cx="393700" cy="279400"/>
+            <a:off x="1358900" y="4851400"/>
+            <a:ext cx="412750" cy="254000"/>
           </a:xfrm>
           <a:prstGeom prst="rect">
             <a:avLst/>
@@ -2910,7 +2910,7 @@
               <a:defRPr spc="0"/>
             </a:pPr>
             <a:r>
-              <a:rPr lang="en-US" sz="1250" b="1" dirty="0" spc="0">
+              <a:rPr lang="en-US" sz="1500" b="1" dirty="0" spc="0">
                 <a:solidFill>
                   <a:srgbClr val="000000"/>
                 </a:solidFill>
@@ -2920,7 +2920,7 @@
               </a:rPr>
               <a:t>03</a:t>
             </a:r>
-            <a:endParaRPr lang="en-US" sz="1250" dirty="0" spc="0"/>
+            <a:endParaRPr lang="en-US" sz="1500" dirty="0" spc="0"/>
           </a:p>
         </p:txBody>
       </p:sp>
@@ -2932,8 +2932,8 @@
         </p:nvSpPr>
         <p:spPr>
           <a:xfrm>
-            <a:off x="1619250" y="4432300"/>
-            <a:ext cx="3429000" cy="222250"/>
+            <a:off x="1936750" y="4864100"/>
+            <a:ext cx="4445000" cy="241300"/>
           </a:xfrm>
           <a:prstGeom prst="rect">
             <a:avLst/>
@@ -2955,7 +2955,7 @@
               <a:defRPr spc="0"/>
             </a:pPr>
             <a:r>
-              <a:rPr lang="en-US" sz="1250" b="1" dirty="0" spc="0">
+              <a:rPr lang="en-US" sz="1400" b="1" dirty="0" spc="0">
                 <a:solidFill>
                   <a:srgbClr val="000000"/>
                 </a:solidFill>
@@ -2965,7 +2965,7 @@
               </a:rPr>
               <a:t>Fund against evidence</a:t>
             </a:r>
-            <a:endParaRPr lang="en-US" sz="1250" dirty="0" spc="0"/>
+            <a:endParaRPr lang="en-US" sz="1400" dirty="0" spc="0"/>
           </a:p>
         </p:txBody>
       </p:sp>
@@ -2977,8 +2977,8 @@
         </p:nvSpPr>
         <p:spPr>
           <a:xfrm>
-            <a:off x="1619250" y="4673600"/>
-            <a:ext cx="4445000" cy="254000"/>
+            <a:off x="1936750" y="5130800"/>
+            <a:ext cx="4635500" cy="412750"/>
           </a:xfrm>
           <a:prstGeom prst="rect">
             <a:avLst/>
@@ -3000,7 +3000,7 @@
               <a:defRPr spc="0"/>
             </a:pPr>
             <a:r>
-              <a:rPr lang="en-US" sz="1050" dirty="0" spc="0">
+              <a:rPr lang="en-US" sz="1300" dirty="0" spc="0">
                 <a:solidFill>
                   <a:srgbClr val="000000"/>
                 </a:solidFill>
@@ -3008,34 +3008,10 @@
                 <a:ea typeface="Arial" pitchFamily="34" charset="-122"/>
                 <a:cs typeface="Arial" pitchFamily="34" charset="-120"/>
               </a:rPr>
-              <a:t>Practice lead and CFO release $60k only after the week-12 gate.</a:t>
+              <a:t>Practice lead and CFO release $60k</a:t>
             </a:r>
-            <a:endParaRPr lang="en-US" sz="1050" dirty="0" spc="0"/>
-          </a:p>
-        </p:txBody>
-      </p:sp>
-      <p:sp>
-        <p:nvSpPr>
-          <p:cNvPr id="28" name="gate-heading"/>
-          <p:cNvSpPr txBox="1"/>
-          <p:nvPr/>
-        </p:nvSpPr>
-        <p:spPr>
-          <a:xfrm>
-            <a:off x="6781800" y="2667000"/>
-            <a:ext cx="5080000" cy="266700"/>
-          </a:xfrm>
-          <a:prstGeom prst="rect">
-            <a:avLst/>
-          </a:prstGeom>
-          <a:noFill/>
-          <a:ln/>
-        </p:spPr>
-        <p:txBody>
-          <a:bodyPr wrap="square" lIns="12700" tIns="12700" rIns="12700" bIns="12700" rtlCol="0" anchor="t">
-            <a:noAutofit/>
-          </a:bodyPr>
-          <a:lstStyle/>
+            <a:endParaRPr lang="en-US" sz="1300" dirty="0" spc="0"/>
+          </a:p>
           <a:p>
             <a:pPr algn="l" indent="0" marL="0">
               <a:lnSpc>
@@ -3045,7 +3021,52 @@
               <a:defRPr spc="0"/>
             </a:pPr>
             <a:r>
-              <a:rPr lang="en-US" sz="1350" b="1" dirty="0" spc="0">
+              <a:rPr lang="en-US" sz="1300" dirty="0" spc="0">
+                <a:solidFill>
+                  <a:srgbClr val="000000"/>
+                </a:solidFill>
+                <a:latin typeface="Arial" pitchFamily="34" charset="0"/>
+                <a:ea typeface="Arial" pitchFamily="34" charset="-122"/>
+                <a:cs typeface="Arial" pitchFamily="34" charset="-120"/>
+              </a:rPr>
+              <a:t>only after the week-12 gate.</a:t>
+            </a:r>
+            <a:endParaRPr lang="en-US" sz="1300" dirty="0" spc="0"/>
+          </a:p>
+        </p:txBody>
+      </p:sp>
+      <p:sp>
+        <p:nvSpPr>
+          <p:cNvPr id="28" name="gate-heading"/>
+          <p:cNvSpPr txBox="1"/>
+          <p:nvPr/>
+        </p:nvSpPr>
+        <p:spPr>
+          <a:xfrm>
+            <a:off x="6731000" y="2927350"/>
+            <a:ext cx="5207000" cy="266700"/>
+          </a:xfrm>
+          <a:prstGeom prst="rect">
+            <a:avLst/>
+          </a:prstGeom>
+          <a:noFill/>
+          <a:ln/>
+        </p:spPr>
+        <p:txBody>
+          <a:bodyPr wrap="square" lIns="12700" tIns="12700" rIns="12700" bIns="12700" rtlCol="0" anchor="t">
+            <a:noAutofit/>
+          </a:bodyPr>
+          <a:lstStyle/>
+          <a:p>
+            <a:pPr algn="l" indent="0" marL="0">
+              <a:lnSpc>
+                <a:spcPct val="100000"/>
+              </a:lnSpc>
+              <a:buNone/>
+              <a:defRPr spc="0"/>
+            </a:pPr>
+            <a:r>
+              <a:rPr lang="en-US" sz="1400" b="1" dirty="0" spc="0">
                 <a:solidFill>
                   <a:srgbClr val="000000"/>
                 </a:solidFill>
@@ -3055,7 +3076,7 @@
               </a:rPr>
               <a:t>WEEK-12 SCALE GATE</a:t>
             </a:r>
-            <a:endParaRPr lang="en-US" sz="1350" dirty="0" spc="0"/>
+            <a:endParaRPr lang="en-US" sz="1400" dirty="0" spc="0"/>
           </a:p>
         </p:txBody>
       </p:sp>
@@ -3171,8 +3192,8 @@
         </p:blipFill>
         <p:spPr>
           <a:xfrm>
-            <a:off x="495300" y="3086100"/>
-            <a:ext cx="317500" cy="317500"/>
+            <a:off x="495300" y="3282950"/>
+            <a:ext cx="546100" cy="546100"/>
           </a:xfrm>
           <a:prstGeom prst="rect">
             <a:avLst/>
@@ -3201,8 +3222,8 @@
         </p:blipFill>
         <p:spPr>
           <a:xfrm>
-            <a:off x="495300" y="3765550"/>
-            <a:ext cx="317500" cy="317500"/>
+            <a:off x="495300" y="4070350"/>
+            <a:ext cx="546100" cy="546100"/>
           </a:xfrm>
           <a:prstGeom prst="rect">
             <a:avLst/>
@@ -3231,8 +3252,8 @@
         </p:blipFill>
         <p:spPr>
           <a:xfrm>
-            <a:off x="495300" y="4445000"/>
-            <a:ext cx="317500" cy="317500"/>
+            <a:off x="495300" y="4832350"/>
+            <a:ext cx="546100" cy="546100"/>
           </a:xfrm>
           <a:prstGeom prst="rect">
             <a:avLst/>

</xml_diff>